<commit_message>
Weekly Wonder: clearer questions for Year 10 and 11 and sixth form
</commit_message>
<xml_diff>
--- a/morning-registration-activities/weekly-wonder/downloads/Weekly_Wonder_Year_10_and_11.pptx
+++ b/morning-registration-activities/weekly-wonder/downloads/Weekly_Wonder_Year_10_and_11.pptx
@@ -2416,7 +2416,7 @@
                 <a:ea typeface="Libre Caslon Display" pitchFamily="34" charset="-122"/>
                 <a:cs typeface="Libre Caslon Display" pitchFamily="34" charset="-120"/>
               </a:rPr>
-              <a:t>Is there anything you would be relieved to be told you were not allowed to do?</a:t>
+              <a:t>Is it ever right to break a rule you think is unfair?</a:t>
             </a:r>
             <a:endParaRPr lang="en-US" sz="3400" dirty="0"/>
           </a:p>
@@ -2686,7 +2686,7 @@
                 <a:ea typeface="Libre Caslon Display" pitchFamily="34" charset="-122"/>
                 <a:cs typeface="Libre Caslon Display" pitchFamily="34" charset="-120"/>
               </a:rPr>
-              <a:t>If you could know one number about yourself that nobody else could see, which number would you choose?</a:t>
+              <a:t>Would you rather be famous for something you did not do, or unknown for something great you did?</a:t>
             </a:r>
             <a:endParaRPr lang="en-US" sz="3400" dirty="0"/>
           </a:p>
@@ -3496,7 +3496,7 @@
                 <a:ea typeface="Libre Caslon Display" pitchFamily="34" charset="-122"/>
                 <a:cs typeface="Libre Caslon Display" pitchFamily="34" charset="-120"/>
               </a:rPr>
-              <a:t>What would change in this school if nobody could see anybody else’s phone?</a:t>
+              <a:t>Is it better to be good at lots of things, or great at one?</a:t>
             </a:r>
             <a:endParaRPr lang="en-US" sz="3400" dirty="0"/>
           </a:p>

</xml_diff>